<commit_message>
docs: create roadmap for project versions
</commit_message>
<xml_diff>
--- a/output/test_placeholder.pptx
+++ b/output/test_placeholder.pptx
@@ -3196,65 +3196,6 @@
           </a:p>
         </p:txBody>
       </p:sp>
-      <p:sp>
-        <p:nvSpPr>
-          <p:cNvPr id="4" name="TextBox 3"/>
-          <p:cNvSpPr txBox="1"/>
-          <p:nvPr/>
-        </p:nvSpPr>
-        <p:spPr>
-          <a:xfrm>
-            <a:off x="7277098" y="1425516"/>
-            <a:ext cx="2838451" cy="253916"/>
-          </a:xfrm>
-          <a:prstGeom prst="rect">
-            <a:avLst/>
-          </a:prstGeom>
-          <a:noFill/>
-        </p:spPr>
-        <p:txBody>
-          <a:bodyPr wrap="square" lIns="0" tIns="0" rIns="0" bIns="0" anchor="ctr">
-            <a:spAutoFit/>
-          </a:bodyPr>
-          <a:lstStyle/>
-          <a:p>
-            <a:pPr algn="ctr"/>
-            <a:r>
-              <a:rPr lang="en-GB" sz="1650" u="none" dirty="0">
-                <a:solidFill>
-                  <a:srgbClr val="472D33"/>
-                </a:solidFill>
-                <a:latin typeface="Poppins ExtraBold"/>
-              </a:rPr>
-              <a:t>{{</a:t>
-            </a:r>
-            <a:r>
-              <a:rPr lang="en-GB" sz="1400" dirty="0">
-                <a:solidFill>
-                  <a:srgbClr val="472D33"/>
-                </a:solidFill>
-                <a:latin typeface="Poppins ExtraBold"/>
-              </a:rPr>
-              <a:t>PRONUNCIATION</a:t>
-            </a:r>
-            <a:r>
-              <a:rPr lang="en-GB" sz="1650" u="none" dirty="0">
-                <a:solidFill>
-                  <a:srgbClr val="472D33"/>
-                </a:solidFill>
-                <a:latin typeface="Poppins ExtraBold"/>
-              </a:rPr>
-              <a:t>}}</a:t>
-            </a:r>
-            <a:endParaRPr sz="1650" u="none" dirty="0">
-              <a:solidFill>
-                <a:srgbClr val="472D33"/>
-              </a:solidFill>
-              <a:latin typeface="Poppins ExtraBold"/>
-            </a:endParaRPr>
-          </a:p>
-        </p:txBody>
-      </p:sp>
       <p:pic>
         <p:nvPicPr>
           <p:cNvPr id="5" name="Picture 4" descr="image.png"/>
@@ -3378,7 +3319,7 @@
                 </a:solidFill>
                 <a:latin typeface="Poppins"/>
               </a:rPr>
-              <a:t>{{MEANING}}</a:t>
+              <a:t>A step-by-step procedure used to solve a problem.</a:t>
             </a:r>
             <a:endParaRPr sz="2700" b="1" i="0" u="none" dirty="0">
               <a:solidFill>
@@ -3634,7 +3575,7 @@
                 </a:solidFill>
                 <a:latin typeface="Noto Sans SemiBold"/>
               </a:rPr>
-              <a:t>{{BASE_FORM}}</a:t>
+              <a:t/>
             </a:r>
             <a:r>
               <a:rPr sz="2000" b="1" dirty="0">
@@ -3666,7 +3607,7 @@
                 </a:solidFill>
                 <a:latin typeface="Noto Sans SemiBold"/>
               </a:rPr>
-              <a:t>{{PRESENT_FORM}}</a:t>
+              <a:t/>
             </a:r>
             <a:r>
               <a:rPr sz="2000" b="1" dirty="0">
@@ -3698,13 +3639,140 @@
                 </a:solidFill>
                 <a:latin typeface="Noto Sans SemiBold"/>
               </a:rPr>
-              <a:t>{{PAST_FORM}}</a:t>
+              <a:t/>
             </a:r>
             <a:endParaRPr sz="2000" b="1" dirty="0">
               <a:solidFill>
                 <a:srgbClr val="475569"/>
               </a:solidFill>
               <a:latin typeface="Noto Sans SemiBold"/>
+            </a:endParaRPr>
+          </a:p>
+        </p:txBody>
+      </p:sp>
+      <p:sp>
+        <p:nvSpPr>
+          <p:cNvPr id="10" name="TextBox 9">
+            <a:extLst>
+              <a:ext uri="{FF2B5EF4-FFF2-40B4-BE49-F238E27FC236}">
+                <a16:creationId xmlns:a16="http://schemas.microsoft.com/office/drawing/2014/main" id="{0A537A4F-4D0A-BFF3-9AE8-11D8B8210CD5}"/>
+              </a:ext>
+            </a:extLst>
+          </p:cNvPr>
+          <p:cNvSpPr txBox="1"/>
+          <p:nvPr/>
+        </p:nvSpPr>
+        <p:spPr>
+          <a:xfrm>
+            <a:off x="4123470" y="1605828"/>
+            <a:ext cx="2190750" cy="923330"/>
+          </a:xfrm>
+          <a:prstGeom prst="rect">
+            <a:avLst/>
+          </a:prstGeom>
+          <a:noFill/>
+        </p:spPr>
+        <p:txBody>
+          <a:bodyPr wrap="square" rtlCol="0">
+            <a:spAutoFit/>
+          </a:bodyPr>
+          <a:lstStyle/>
+          <a:p>
+            <a:pPr algn="ctr"/>
+            <a:r>
+              <a:rPr lang="en-GB" b="1" dirty="0"/>
+              <a:t>एल्गोरिदम, അൽഗോരിതം,</a:t>
+            </a:r>
+            <a:br>
+              <a:rPr lang="en-GB" b="1" dirty="0"/>
+            </a:br>
+            <a:r>
+              <a:rPr lang="en-GB" b="1" dirty="0"/>
+              <a:t>அல்காரிதம்</a:t>
+            </a:r>
+            <a:endParaRPr lang="en-IN" b="1" dirty="0"/>
+          </a:p>
+        </p:txBody>
+      </p:sp>
+      <p:sp>
+        <p:nvSpPr>
+          <p:cNvPr id="15" name="TextBox 14">
+            <a:extLst>
+              <a:ext uri="{FF2B5EF4-FFF2-40B4-BE49-F238E27FC236}">
+                <a16:creationId xmlns:a16="http://schemas.microsoft.com/office/drawing/2014/main" id="{9546E987-1B6A-FE97-9592-C215495A06B3}"/>
+              </a:ext>
+            </a:extLst>
+          </p:cNvPr>
+          <p:cNvSpPr txBox="1"/>
+          <p:nvPr/>
+        </p:nvSpPr>
+        <p:spPr>
+          <a:xfrm>
+            <a:off x="314325" y="6055475"/>
+            <a:ext cx="2381250" cy="369332"/>
+          </a:xfrm>
+          <a:prstGeom prst="rect">
+            <a:avLst/>
+          </a:prstGeom>
+          <a:noFill/>
+        </p:spPr>
+        <p:txBody>
+          <a:bodyPr wrap="square" rtlCol="0">
+            <a:spAutoFit/>
+          </a:bodyPr>
+          <a:lstStyle/>
+          <a:p>
+            <a:r>
+              <a:rPr lang="en-GB" dirty="0"/>
+              <a:t>1/20</a:t>
+            </a:r>
+            <a:endParaRPr lang="en-IN" dirty="0"/>
+          </a:p>
+        </p:txBody>
+      </p:sp>
+      <p:sp>
+        <p:nvSpPr>
+          <p:cNvPr id="17" name="TextBox 16">
+            <a:extLst>
+              <a:ext uri="{FF2B5EF4-FFF2-40B4-BE49-F238E27FC236}">
+                <a16:creationId xmlns:a16="http://schemas.microsoft.com/office/drawing/2014/main" id="{D9ED7E96-20C9-C5ED-2E4C-C2B78876EA54}"/>
+              </a:ext>
+            </a:extLst>
+          </p:cNvPr>
+          <p:cNvSpPr txBox="1"/>
+          <p:nvPr/>
+        </p:nvSpPr>
+        <p:spPr>
+          <a:xfrm>
+            <a:off x="7277098" y="1425516"/>
+            <a:ext cx="2838451" cy="253916"/>
+          </a:xfrm>
+          <a:prstGeom prst="rect">
+            <a:avLst/>
+          </a:prstGeom>
+          <a:noFill/>
+        </p:spPr>
+        <p:txBody>
+          <a:bodyPr wrap="square" lIns="0" tIns="0" rIns="0" bIns="0" anchor="ctr">
+            <a:spAutoFit/>
+          </a:bodyPr>
+          <a:lstStyle/>
+          <a:p>
+            <a:pPr algn="ctr"/>
+            <a:r>
+              <a:rPr lang="en-GB" sz="1650" dirty="0">
+                <a:solidFill>
+                  <a:srgbClr val="472D33"/>
+                </a:solidFill>
+                <a:latin typeface="Poppins ExtraBold"/>
+              </a:rPr>
+              <a:t>/ˈælɡəˌrɪðəm/</a:t>
+            </a:r>
+            <a:endParaRPr sz="1650" u="none" dirty="0">
+              <a:solidFill>
+                <a:srgbClr val="472D33"/>
+              </a:solidFill>
+              <a:latin typeface="Poppins ExtraBold"/>
             </a:endParaRPr>
           </a:p>
         </p:txBody>
@@ -3885,31 +3953,13 @@
           <a:p>
             <a:pPr algn="ctr"/>
             <a:r>
-              <a:rPr lang="en-GB" sz="1650" u="none" dirty="0">
+              <a:rPr lang="en-GB" sz="1650" dirty="0">
                 <a:solidFill>
                   <a:srgbClr val="472D33"/>
                 </a:solidFill>
                 <a:latin typeface="Poppins ExtraBold"/>
               </a:rPr>
-              <a:t>{{</a:t>
-            </a:r>
-            <a:r>
-              <a:rPr lang="en-GB" sz="1400" dirty="0">
-                <a:solidFill>
-                  <a:srgbClr val="472D33"/>
-                </a:solidFill>
-                <a:latin typeface="Poppins ExtraBold"/>
-              </a:rPr>
-              <a:t>PRONUNCIATION</a:t>
-            </a:r>
-            <a:r>
-              <a:rPr lang="en-GB" sz="1650" u="none" dirty="0">
-                <a:solidFill>
-                  <a:srgbClr val="472D33"/>
-                </a:solidFill>
-                <a:latin typeface="Poppins ExtraBold"/>
-              </a:rPr>
-              <a:t>}}</a:t>
+              <a:t>/ˈælɡəˌrɪðəm/</a:t>
             </a:r>
             <a:endParaRPr sz="1650" u="none" dirty="0">
               <a:solidFill>
@@ -4067,7 +4117,7 @@
                 </a:solidFill>
                 <a:latin typeface="Poppins"/>
               </a:rPr>
-              <a:t>{{MEANING}}</a:t>
+              <a:t>A step-by-step procedure used to solve a problem.</a:t>
             </a:r>
             <a:endParaRPr sz="2700" b="1" i="0" u="none" dirty="0">
               <a:solidFill>
@@ -4329,7 +4379,7 @@
                 </a:solidFill>
                 <a:latin typeface="Noto Sans SemiBold"/>
               </a:rPr>
-              <a:t>{{BASE_FORM}}</a:t>
+              <a:t/>
             </a:r>
             <a:r>
               <a:rPr sz="2000" b="1" dirty="0">
@@ -4361,7 +4411,7 @@
                 </a:solidFill>
                 <a:latin typeface="Noto Sans SemiBold"/>
               </a:rPr>
-              <a:t>{{PRESENT_FORM}}</a:t>
+              <a:t/>
             </a:r>
             <a:r>
               <a:rPr sz="2000" b="1" dirty="0">
@@ -4393,7 +4443,7 @@
                 </a:solidFill>
                 <a:latin typeface="Noto Sans SemiBold"/>
               </a:rPr>
-              <a:t>{{PAST_FORM}}</a:t>
+              <a:t/>
             </a:r>
             <a:endParaRPr sz="2000" b="1" dirty="0">
               <a:solidFill>
@@ -4439,7 +4489,7 @@
                 </a:solidFill>
                 <a:latin typeface="Poppins ExtraBold"/>
               </a:rPr>
-              <a:t>{{PAST_SENTENCE}}</a:t>
+              <a:t>Yesterday I learned an algorithm.</a:t>
             </a:r>
             <a:endParaRPr sz="2400" b="0" i="0" u="none" dirty="0">
               <a:solidFill>
@@ -4447,6 +4497,86 @@
               </a:solidFill>
               <a:latin typeface="Poppins ExtraBold"/>
             </a:endParaRPr>
+          </a:p>
+        </p:txBody>
+      </p:sp>
+      <p:sp>
+        <p:nvSpPr>
+          <p:cNvPr id="13" name="TextBox 12">
+            <a:extLst>
+              <a:ext uri="{FF2B5EF4-FFF2-40B4-BE49-F238E27FC236}">
+                <a16:creationId xmlns:a16="http://schemas.microsoft.com/office/drawing/2014/main" id="{905DD7DE-7D39-D652-3399-C6F0644DC3D3}"/>
+              </a:ext>
+            </a:extLst>
+          </p:cNvPr>
+          <p:cNvSpPr txBox="1"/>
+          <p:nvPr/>
+        </p:nvSpPr>
+        <p:spPr>
+          <a:xfrm>
+            <a:off x="4819651" y="4057650"/>
+            <a:ext cx="2190750" cy="923330"/>
+          </a:xfrm>
+          <a:prstGeom prst="rect">
+            <a:avLst/>
+          </a:prstGeom>
+          <a:noFill/>
+        </p:spPr>
+        <p:txBody>
+          <a:bodyPr wrap="square" rtlCol="0">
+            <a:spAutoFit/>
+          </a:bodyPr>
+          <a:lstStyle/>
+          <a:p>
+            <a:pPr algn="ctr"/>
+            <a:r>
+              <a:rPr lang="en-GB" b="1" dirty="0"/>
+              <a:t>एल्गोरिदम, അൽഗോരിതം,</a:t>
+            </a:r>
+            <a:br>
+              <a:rPr lang="en-GB" b="1" dirty="0"/>
+            </a:br>
+            <a:r>
+              <a:rPr lang="en-GB" b="1" dirty="0"/>
+              <a:t>அல்காரிதம்</a:t>
+            </a:r>
+            <a:endParaRPr lang="en-IN" b="1" dirty="0"/>
+          </a:p>
+        </p:txBody>
+      </p:sp>
+      <p:sp>
+        <p:nvSpPr>
+          <p:cNvPr id="14" name="TextBox 13">
+            <a:extLst>
+              <a:ext uri="{FF2B5EF4-FFF2-40B4-BE49-F238E27FC236}">
+                <a16:creationId xmlns:a16="http://schemas.microsoft.com/office/drawing/2014/main" id="{297F8D2F-B09A-B1B4-583C-48301F7AAEF1}"/>
+              </a:ext>
+            </a:extLst>
+          </p:cNvPr>
+          <p:cNvSpPr txBox="1"/>
+          <p:nvPr/>
+        </p:nvSpPr>
+        <p:spPr>
+          <a:xfrm>
+            <a:off x="314325" y="6055475"/>
+            <a:ext cx="2381250" cy="369332"/>
+          </a:xfrm>
+          <a:prstGeom prst="rect">
+            <a:avLst/>
+          </a:prstGeom>
+          <a:noFill/>
+        </p:spPr>
+        <p:txBody>
+          <a:bodyPr wrap="square" rtlCol="0">
+            <a:spAutoFit/>
+          </a:bodyPr>
+          <a:lstStyle/>
+          <a:p>
+            <a:r>
+              <a:rPr lang="en-GB" dirty="0"/>
+              <a:t>1/20</a:t>
+            </a:r>
+            <a:endParaRPr lang="en-IN" dirty="0"/>
           </a:p>
         </p:txBody>
       </p:sp>
@@ -4631,31 +4761,13 @@
           <a:p>
             <a:pPr algn="ctr"/>
             <a:r>
-              <a:rPr lang="en-GB" sz="1650" u="none" dirty="0">
+              <a:rPr lang="en-GB" sz="1650" dirty="0">
                 <a:solidFill>
                   <a:srgbClr val="472D33"/>
                 </a:solidFill>
                 <a:latin typeface="Poppins ExtraBold"/>
               </a:rPr>
-              <a:t>{{</a:t>
-            </a:r>
-            <a:r>
-              <a:rPr lang="en-GB" sz="1400" dirty="0">
-                <a:solidFill>
-                  <a:srgbClr val="472D33"/>
-                </a:solidFill>
-                <a:latin typeface="Poppins ExtraBold"/>
-              </a:rPr>
-              <a:t>PRONUNCIATION</a:t>
-            </a:r>
-            <a:r>
-              <a:rPr lang="en-GB" sz="1650" u="none" dirty="0">
-                <a:solidFill>
-                  <a:srgbClr val="472D33"/>
-                </a:solidFill>
-                <a:latin typeface="Poppins ExtraBold"/>
-              </a:rPr>
-              <a:t>}}</a:t>
+              <a:t>/ˈælɡəˌrɪðəm/</a:t>
             </a:r>
             <a:endParaRPr sz="1650" u="none" dirty="0">
               <a:solidFill>
@@ -4813,7 +4925,7 @@
                 </a:solidFill>
                 <a:latin typeface="Poppins"/>
               </a:rPr>
-              <a:t>{{MEANING}}</a:t>
+              <a:t>A step-by-step procedure used to solve a problem.</a:t>
             </a:r>
             <a:endParaRPr sz="2700" b="1" i="0" u="none" dirty="0">
               <a:solidFill>
@@ -5075,7 +5187,7 @@
                 </a:solidFill>
                 <a:latin typeface="Noto Sans SemiBold"/>
               </a:rPr>
-              <a:t>{{BASE_FORM}}</a:t>
+              <a:t/>
             </a:r>
             <a:r>
               <a:rPr sz="2000" b="1" dirty="0">
@@ -5107,7 +5219,7 @@
                 </a:solidFill>
                 <a:latin typeface="Noto Sans SemiBold"/>
               </a:rPr>
-              <a:t>{{PRESENT_FORM}}</a:t>
+              <a:t/>
             </a:r>
             <a:r>
               <a:rPr sz="2000" b="1" dirty="0">
@@ -5139,7 +5251,7 @@
                 </a:solidFill>
                 <a:latin typeface="Noto Sans SemiBold"/>
               </a:rPr>
-              <a:t>{{PAST_FORM}}</a:t>
+              <a:t/>
             </a:r>
             <a:endParaRPr sz="2000" b="1" dirty="0">
               <a:solidFill>
@@ -5185,7 +5297,7 @@
                 </a:solidFill>
                 <a:latin typeface="Poppins ExtraBold"/>
               </a:rPr>
-              <a:t>{{PAST_SENTENCE}}</a:t>
+              <a:t>Yesterday I learned an algorithm.</a:t>
             </a:r>
             <a:endParaRPr sz="2400" b="0" i="0" u="none" dirty="0">
               <a:solidFill>
@@ -5257,6 +5369,122 @@
               </a:solidFill>
               <a:latin typeface="Poppins ExtraBold"/>
             </a:endParaRPr>
+          </a:p>
+        </p:txBody>
+      </p:sp>
+      <p:sp>
+        <p:nvSpPr>
+          <p:cNvPr id="13" name="TextBox 12">
+            <a:extLst>
+              <a:ext uri="{FF2B5EF4-FFF2-40B4-BE49-F238E27FC236}">
+                <a16:creationId xmlns:a16="http://schemas.microsoft.com/office/drawing/2014/main" id="{B1CB6EE9-A13A-C353-7C57-19E97573E6EC}"/>
+              </a:ext>
+            </a:extLst>
+          </p:cNvPr>
+          <p:cNvSpPr txBox="1"/>
+          <p:nvPr/>
+        </p:nvSpPr>
+        <p:spPr>
+          <a:xfrm>
+            <a:off x="4819651" y="4057650"/>
+            <a:ext cx="2190750" cy="923330"/>
+          </a:xfrm>
+          <a:prstGeom prst="rect">
+            <a:avLst/>
+          </a:prstGeom>
+          <a:noFill/>
+        </p:spPr>
+        <p:txBody>
+          <a:bodyPr wrap="square" rtlCol="0">
+            <a:spAutoFit/>
+          </a:bodyPr>
+          <a:lstStyle/>
+          <a:p>
+            <a:pPr algn="ctr"/>
+            <a:r>
+              <a:rPr lang="en-GB" b="1" dirty="0"/>
+              <a:t>एल्गोरिदम, അൽഗോരിതം,</a:t>
+            </a:r>
+            <a:br>
+              <a:rPr lang="en-GB" b="1" dirty="0"/>
+            </a:br>
+            <a:r>
+              <a:rPr lang="en-GB" b="1" dirty="0"/>
+              <a:t>அல்காரிதம்</a:t>
+            </a:r>
+            <a:endParaRPr lang="en-IN" b="1" dirty="0"/>
+          </a:p>
+        </p:txBody>
+      </p:sp>
+      <p:sp>
+        <p:nvSpPr>
+          <p:cNvPr id="14" name="TextBox 13">
+            <a:extLst>
+              <a:ext uri="{FF2B5EF4-FFF2-40B4-BE49-F238E27FC236}">
+                <a16:creationId xmlns:a16="http://schemas.microsoft.com/office/drawing/2014/main" id="{DA549B56-9DFE-47C2-5021-87EA5CA59DD7}"/>
+              </a:ext>
+            </a:extLst>
+          </p:cNvPr>
+          <p:cNvSpPr txBox="1"/>
+          <p:nvPr/>
+        </p:nvSpPr>
+        <p:spPr>
+          <a:xfrm>
+            <a:off x="314325" y="6055475"/>
+            <a:ext cx="2381250" cy="369332"/>
+          </a:xfrm>
+          <a:prstGeom prst="rect">
+            <a:avLst/>
+          </a:prstGeom>
+          <a:noFill/>
+        </p:spPr>
+        <p:txBody>
+          <a:bodyPr wrap="square" rtlCol="0">
+            <a:spAutoFit/>
+          </a:bodyPr>
+          <a:lstStyle/>
+          <a:p>
+            <a:r>
+              <a:rPr lang="en-GB" dirty="0"/>
+              <a:t>1/20</a:t>
+            </a:r>
+            <a:endParaRPr lang="en-IN" dirty="0"/>
+          </a:p>
+        </p:txBody>
+      </p:sp>
+      <p:sp>
+        <p:nvSpPr>
+          <p:cNvPr id="17" name="TextBox 16">
+            <a:extLst>
+              <a:ext uri="{FF2B5EF4-FFF2-40B4-BE49-F238E27FC236}">
+                <a16:creationId xmlns:a16="http://schemas.microsoft.com/office/drawing/2014/main" id="{740F27BC-5AF1-DB1A-0866-514662520B18}"/>
+              </a:ext>
+            </a:extLst>
+          </p:cNvPr>
+          <p:cNvSpPr txBox="1"/>
+          <p:nvPr/>
+        </p:nvSpPr>
+        <p:spPr>
+          <a:xfrm>
+            <a:off x="3343716" y="5465198"/>
+            <a:ext cx="2753032" cy="369332"/>
+          </a:xfrm>
+          <a:prstGeom prst="rect">
+            <a:avLst/>
+          </a:prstGeom>
+          <a:noFill/>
+        </p:spPr>
+        <p:txBody>
+          <a:bodyPr wrap="square" rtlCol="0">
+            <a:spAutoFit/>
+          </a:bodyPr>
+          <a:lstStyle/>
+          <a:p>
+            <a:r>
+              <a:rPr lang="en-GB" dirty="0"/>
+              <a:t>I use an algorithm to solve the problem.</a:t>
+            </a:r>
+            <a:endParaRPr lang="en-IN" dirty="0"/>
           </a:p>
         </p:txBody>
       </p:sp>
@@ -5441,31 +5669,13 @@
           <a:p>
             <a:pPr algn="ctr"/>
             <a:r>
-              <a:rPr lang="en-GB" sz="1650" u="none" dirty="0">
+              <a:rPr lang="en-GB" sz="1650" dirty="0">
                 <a:solidFill>
                   <a:srgbClr val="472D33"/>
                 </a:solidFill>
                 <a:latin typeface="Poppins ExtraBold"/>
               </a:rPr>
-              <a:t>{{</a:t>
-            </a:r>
-            <a:r>
-              <a:rPr lang="en-GB" sz="1400" dirty="0">
-                <a:solidFill>
-                  <a:srgbClr val="472D33"/>
-                </a:solidFill>
-                <a:latin typeface="Poppins ExtraBold"/>
-              </a:rPr>
-              <a:t>PRONUNCIATION</a:t>
-            </a:r>
-            <a:r>
-              <a:rPr lang="en-GB" sz="1650" u="none" dirty="0">
-                <a:solidFill>
-                  <a:srgbClr val="472D33"/>
-                </a:solidFill>
-                <a:latin typeface="Poppins ExtraBold"/>
-              </a:rPr>
-              <a:t>}}</a:t>
+              <a:t>/ˈælɡəˌrɪðəm/</a:t>
             </a:r>
             <a:endParaRPr sz="1650" u="none" dirty="0">
               <a:solidFill>
@@ -5623,7 +5833,7 @@
                 </a:solidFill>
                 <a:latin typeface="Poppins"/>
               </a:rPr>
-              <a:t>{{MEANING}}</a:t>
+              <a:t>A step-by-step procedure used to solve a problem.</a:t>
             </a:r>
             <a:endParaRPr sz="2700" b="1" i="0" u="none" dirty="0">
               <a:solidFill>
@@ -5885,7 +6095,7 @@
                 </a:solidFill>
                 <a:latin typeface="Noto Sans SemiBold"/>
               </a:rPr>
-              <a:t>{{BASE_FORM}}</a:t>
+              <a:t/>
             </a:r>
             <a:r>
               <a:rPr sz="2000" b="1" dirty="0">
@@ -5917,7 +6127,7 @@
                 </a:solidFill>
                 <a:latin typeface="Noto Sans SemiBold"/>
               </a:rPr>
-              <a:t>{{PRESENT_FORM}}</a:t>
+              <a:t/>
             </a:r>
             <a:r>
               <a:rPr sz="2000" b="1" dirty="0">
@@ -5949,7 +6159,7 @@
                 </a:solidFill>
                 <a:latin typeface="Noto Sans SemiBold"/>
               </a:rPr>
-              <a:t>{{PAST_FORM}}</a:t>
+              <a:t/>
             </a:r>
             <a:endParaRPr sz="2000" b="1" dirty="0">
               <a:solidFill>
@@ -5995,7 +6205,7 @@
                 </a:solidFill>
                 <a:latin typeface="Poppins ExtraBold"/>
               </a:rPr>
-              <a:t>{{PAST_SENTENCE}}</a:t>
+              <a:t>Yesterday I learned an algorithm.</a:t>
             </a:r>
             <a:endParaRPr sz="2400" b="0" i="0" u="none" dirty="0">
               <a:solidFill>
@@ -6149,6 +6359,158 @@
               </a:solidFill>
               <a:latin typeface="Poppins ExtraBold"/>
             </a:endParaRPr>
+          </a:p>
+        </p:txBody>
+      </p:sp>
+      <p:sp>
+        <p:nvSpPr>
+          <p:cNvPr id="14" name="TextBox 13">
+            <a:extLst>
+              <a:ext uri="{FF2B5EF4-FFF2-40B4-BE49-F238E27FC236}">
+                <a16:creationId xmlns:a16="http://schemas.microsoft.com/office/drawing/2014/main" id="{E39B2766-06EB-ACF1-5F47-992137BDF7AC}"/>
+              </a:ext>
+            </a:extLst>
+          </p:cNvPr>
+          <p:cNvSpPr txBox="1"/>
+          <p:nvPr/>
+        </p:nvSpPr>
+        <p:spPr>
+          <a:xfrm>
+            <a:off x="3794329" y="2583039"/>
+            <a:ext cx="2190750" cy="923330"/>
+          </a:xfrm>
+          <a:prstGeom prst="rect">
+            <a:avLst/>
+          </a:prstGeom>
+          <a:noFill/>
+        </p:spPr>
+        <p:txBody>
+          <a:bodyPr wrap="square" rtlCol="0">
+            <a:spAutoFit/>
+          </a:bodyPr>
+          <a:lstStyle/>
+          <a:p>
+            <a:pPr algn="ctr"/>
+            <a:r>
+              <a:rPr lang="en-GB" b="1" dirty="0"/>
+              <a:t>एल्गोरिदम, അൽഗോരിതം,</a:t>
+            </a:r>
+            <a:br>
+              <a:rPr lang="en-GB" b="1" dirty="0"/>
+            </a:br>
+            <a:r>
+              <a:rPr lang="en-GB" b="1" dirty="0"/>
+              <a:t>அல்காரிதம்</a:t>
+            </a:r>
+            <a:endParaRPr lang="en-IN" b="1" dirty="0"/>
+          </a:p>
+        </p:txBody>
+      </p:sp>
+      <p:sp>
+        <p:nvSpPr>
+          <p:cNvPr id="17" name="TextBox 16">
+            <a:extLst>
+              <a:ext uri="{FF2B5EF4-FFF2-40B4-BE49-F238E27FC236}">
+                <a16:creationId xmlns:a16="http://schemas.microsoft.com/office/drawing/2014/main" id="{A2BDFC54-52D3-1CC7-0794-2AB566E6EA00}"/>
+              </a:ext>
+            </a:extLst>
+          </p:cNvPr>
+          <p:cNvSpPr txBox="1"/>
+          <p:nvPr/>
+        </p:nvSpPr>
+        <p:spPr>
+          <a:xfrm>
+            <a:off x="314325" y="6055475"/>
+            <a:ext cx="2381250" cy="369332"/>
+          </a:xfrm>
+          <a:prstGeom prst="rect">
+            <a:avLst/>
+          </a:prstGeom>
+          <a:noFill/>
+        </p:spPr>
+        <p:txBody>
+          <a:bodyPr wrap="square" rtlCol="0">
+            <a:spAutoFit/>
+          </a:bodyPr>
+          <a:lstStyle/>
+          <a:p>
+            <a:r>
+              <a:rPr lang="en-GB" dirty="0"/>
+              <a:t>1/20</a:t>
+            </a:r>
+            <a:endParaRPr lang="en-IN" dirty="0"/>
+          </a:p>
+        </p:txBody>
+      </p:sp>
+      <p:sp>
+        <p:nvSpPr>
+          <p:cNvPr id="13" name="TextBox 12">
+            <a:extLst>
+              <a:ext uri="{FF2B5EF4-FFF2-40B4-BE49-F238E27FC236}">
+                <a16:creationId xmlns:a16="http://schemas.microsoft.com/office/drawing/2014/main" id="{1B52620E-AE51-05B1-BFE9-0843E5D61517}"/>
+              </a:ext>
+            </a:extLst>
+          </p:cNvPr>
+          <p:cNvSpPr txBox="1"/>
+          <p:nvPr/>
+        </p:nvSpPr>
+        <p:spPr>
+          <a:xfrm>
+            <a:off x="3191316" y="5312798"/>
+            <a:ext cx="2753032" cy="369332"/>
+          </a:xfrm>
+          <a:prstGeom prst="rect">
+            <a:avLst/>
+          </a:prstGeom>
+          <a:noFill/>
+        </p:spPr>
+        <p:txBody>
+          <a:bodyPr wrap="square" rtlCol="0">
+            <a:spAutoFit/>
+          </a:bodyPr>
+          <a:lstStyle/>
+          <a:p>
+            <a:r>
+              <a:rPr lang="en-GB" dirty="0"/>
+              <a:t>I use an algorithm to solve the problem.</a:t>
+            </a:r>
+            <a:endParaRPr lang="en-IN" dirty="0"/>
+          </a:p>
+        </p:txBody>
+      </p:sp>
+      <p:sp>
+        <p:nvSpPr>
+          <p:cNvPr id="20" name="TextBox 19">
+            <a:extLst>
+              <a:ext uri="{FF2B5EF4-FFF2-40B4-BE49-F238E27FC236}">
+                <a16:creationId xmlns:a16="http://schemas.microsoft.com/office/drawing/2014/main" id="{4799948D-503D-1BC8-A206-EA54AED1F16D}"/>
+              </a:ext>
+            </a:extLst>
+          </p:cNvPr>
+          <p:cNvSpPr txBox="1"/>
+          <p:nvPr/>
+        </p:nvSpPr>
+        <p:spPr>
+          <a:xfrm>
+            <a:off x="4276419" y="6006622"/>
+            <a:ext cx="2753032" cy="369332"/>
+          </a:xfrm>
+          <a:prstGeom prst="rect">
+            <a:avLst/>
+          </a:prstGeom>
+          <a:noFill/>
+        </p:spPr>
+        <p:txBody>
+          <a:bodyPr wrap="square" rtlCol="0">
+            <a:spAutoFit/>
+          </a:bodyPr>
+          <a:lstStyle/>
+          <a:p>
+            <a:r>
+              <a:rPr lang="en-GB" dirty="0"/>
+              <a:t>Tomorrow I will study a new algorithm.</a:t>
+            </a:r>
+            <a:endParaRPr lang="en-IN" dirty="0"/>
           </a:p>
         </p:txBody>
       </p:sp>

</xml_diff>